<commit_message>
Update template and preserve technical_drawing tag
</commit_message>
<xml_diff>
--- a/template.pptx
+++ b/template.pptx
@@ -142,7 +142,7 @@
           <a:p>
             <a:fld id="{C2BA462C-7B8E-41CC-A074-F2F31662260A}" type="datetimeFigureOut">
               <a:rPr lang="en-GB" smtClean="0"/>
-              <a:t>26/06/2026</a:t>
+              <a:t>29/06/2026</a:t>
             </a:fld>
             <a:endParaRPr lang="en-GB"/>
           </a:p>
@@ -319,7 +319,7 @@
           <a:p>
             <a:fld id="{1082EEEB-836D-594B-9F80-250148AC8146}" type="datetimeFigureOut">
               <a:rPr lang="en-US" smtClean="0"/>
-              <a:t>6/26/2026</a:t>
+              <a:t>6/29/2026</a:t>
             </a:fld>
             <a:endParaRPr lang="en-US"/>
           </a:p>
@@ -2628,7 +2628,7 @@
         </p:nvSpPr>
         <p:spPr>
           <a:xfrm>
-            <a:off x="3709504" y="384911"/>
+            <a:off x="3887304" y="325920"/>
             <a:ext cx="7239000" cy="523220"/>
           </a:xfrm>
           <a:prstGeom prst="rect">
@@ -2649,15 +2649,7 @@
             </a:pPr>
             <a:r>
               <a:rPr lang="en-GB" sz="2800" dirty="0"/>
-              <a:t>{{</a:t>
-            </a:r>
-            <a:r>
-              <a:rPr lang="en-GB" sz="2800" dirty="0" err="1"/>
-              <a:t>product_title</a:t>
-            </a:r>
-            <a:r>
-              <a:rPr lang="en-GB" sz="2800" dirty="0"/>
-              <a:t>}}</a:t>
+              <a:t>{{part_number_1}}</a:t>
             </a:r>
             <a:endParaRPr lang="en-GB" sz="2800" b="1" i="0" dirty="0">
               <a:solidFill>
@@ -4250,15 +4242,7 @@
             </a:pPr>
             <a:r>
               <a:rPr lang="en-GB" sz="2800" dirty="0"/>
-              <a:t>{{</a:t>
-            </a:r>
-            <a:r>
-              <a:rPr lang="en-GB" sz="2800" dirty="0" err="1"/>
-              <a:t>product_title</a:t>
-            </a:r>
-            <a:r>
-              <a:rPr lang="en-GB" sz="2800" dirty="0"/>
-              <a:t>}}</a:t>
+              <a:t>{{part_number_1}}</a:t>
             </a:r>
             <a:endParaRPr lang="en-GB" sz="2800" b="1" i="0" dirty="0">
               <a:solidFill>
@@ -12939,10 +12923,10 @@
       </p:sp>
       <p:sp>
         <p:nvSpPr>
-          <p:cNvPr id="17" name="TextBox 16">
+          <p:cNvPr id="3" name="TextBox 2">
             <a:extLst>
               <a:ext uri="{FF2B5EF4-FFF2-40B4-BE49-F238E27FC236}">
-                <a16:creationId xmlns:a16="http://schemas.microsoft.com/office/drawing/2014/main" id="{24824068-31E3-D46F-492A-0B66D5514B05}"/>
+                <a16:creationId xmlns:a16="http://schemas.microsoft.com/office/drawing/2014/main" id="{53EEFB74-84AC-40D3-D05E-DEFFF4BB7BCD}"/>
               </a:ext>
             </a:extLst>
           </p:cNvPr>
@@ -12951,7 +12935,7 @@
         </p:nvSpPr>
         <p:spPr>
           <a:xfrm>
-            <a:off x="3860800" y="252942"/>
+            <a:off x="3871844" y="417306"/>
             <a:ext cx="7239000" cy="523220"/>
           </a:xfrm>
           <a:prstGeom prst="rect">
@@ -12972,15 +12956,7 @@
             </a:pPr>
             <a:r>
               <a:rPr lang="en-GB" sz="2800" dirty="0"/>
-              <a:t>{{</a:t>
-            </a:r>
-            <a:r>
-              <a:rPr lang="en-GB" sz="2800" dirty="0" err="1"/>
-              <a:t>product_title</a:t>
-            </a:r>
-            <a:r>
-              <a:rPr lang="en-GB" sz="2800" dirty="0"/>
-              <a:t>}}</a:t>
+              <a:t>{{part_number_1}}</a:t>
             </a:r>
             <a:endParaRPr lang="en-GB" sz="2800" b="1" i="0" dirty="0">
               <a:solidFill>
@@ -23046,10 +23022,10 @@
       </p:graphicFrame>
       <p:sp>
         <p:nvSpPr>
-          <p:cNvPr id="4" name="TextBox 3">
+          <p:cNvPr id="6" name="TextBox 5">
             <a:extLst>
               <a:ext uri="{FF2B5EF4-FFF2-40B4-BE49-F238E27FC236}">
-                <a16:creationId xmlns:a16="http://schemas.microsoft.com/office/drawing/2014/main" id="{36525A80-2451-A546-AB91-E6E884999DF7}"/>
+                <a16:creationId xmlns:a16="http://schemas.microsoft.com/office/drawing/2014/main" id="{40EEBB1F-04E3-5C44-4A4D-94C5EFA7E80E}"/>
               </a:ext>
             </a:extLst>
           </p:cNvPr>
@@ -23058,8 +23034,8 @@
         </p:nvSpPr>
         <p:spPr>
           <a:xfrm>
-            <a:off x="4219432" y="488434"/>
-            <a:ext cx="8940800" cy="369332"/>
+            <a:off x="3822700" y="369177"/>
+            <a:ext cx="7239000" cy="523220"/>
           </a:xfrm>
           <a:prstGeom prst="rect">
             <a:avLst/>
@@ -23078,18 +23054,10 @@
               </a:spcBef>
             </a:pPr>
             <a:r>
-              <a:rPr lang="en-GB" sz="1800" dirty="0"/>
-              <a:t>{{</a:t>
+              <a:rPr lang="en-GB" sz="2800" dirty="0"/>
+              <a:t>{{part_number_1}}</a:t>
             </a:r>
-            <a:r>
-              <a:rPr lang="en-GB" sz="1800" dirty="0" err="1"/>
-              <a:t>product_title</a:t>
-            </a:r>
-            <a:r>
-              <a:rPr lang="en-GB" sz="1800" dirty="0"/>
-              <a:t>}}</a:t>
-            </a:r>
-            <a:endParaRPr lang="en-GB" sz="1800" b="1" i="0" dirty="0">
+            <a:endParaRPr lang="en-GB" sz="2800" b="1" i="0" dirty="0">
               <a:solidFill>
                 <a:srgbClr val="004455"/>
               </a:solidFill>
@@ -34320,7 +34288,7 @@
         </p:nvSpPr>
         <p:spPr>
           <a:xfrm>
-            <a:off x="4186416" y="488434"/>
+            <a:off x="4180113" y="492606"/>
             <a:ext cx="8940800" cy="369332"/>
           </a:xfrm>
           <a:prstGeom prst="rect">
@@ -34341,15 +34309,7 @@
             </a:pPr>
             <a:r>
               <a:rPr lang="en-GB" sz="1800" dirty="0"/>
-              <a:t>{{</a:t>
-            </a:r>
-            <a:r>
-              <a:rPr lang="en-GB" sz="1800" dirty="0" err="1"/>
-              <a:t>product_title</a:t>
-            </a:r>
-            <a:r>
-              <a:rPr lang="en-GB" sz="1800" dirty="0"/>
-              <a:t>}}</a:t>
+              <a:t>{{part_number_1}}</a:t>
             </a:r>
             <a:endParaRPr lang="en-GB" sz="1800" b="1" i="0" dirty="0">
               <a:solidFill>
@@ -34488,15 +34448,7 @@
             </a:pPr>
             <a:r>
               <a:rPr lang="en-GB" sz="2800" dirty="0"/>
-              <a:t>{{</a:t>
-            </a:r>
-            <a:r>
-              <a:rPr lang="en-GB" sz="2800" dirty="0" err="1"/>
-              <a:t>product_title</a:t>
-            </a:r>
-            <a:r>
-              <a:rPr lang="en-GB" sz="2800" dirty="0"/>
-              <a:t>}}</a:t>
+              <a:t>{{part_number_1}}</a:t>
             </a:r>
             <a:endParaRPr lang="en-GB" sz="2800" b="1" i="0" dirty="0">
               <a:solidFill>
@@ -37733,7 +37685,7 @@
         </p:nvSpPr>
         <p:spPr>
           <a:xfrm>
-            <a:off x="3683000" y="514552"/>
+            <a:off x="3543300" y="349452"/>
             <a:ext cx="7239000" cy="523220"/>
           </a:xfrm>
           <a:prstGeom prst="rect">
@@ -37754,15 +37706,7 @@
             </a:pPr>
             <a:r>
               <a:rPr lang="en-GB" sz="2800" dirty="0"/>
-              <a:t>{{</a:t>
-            </a:r>
-            <a:r>
-              <a:rPr lang="en-GB" sz="2800" dirty="0" err="1"/>
-              <a:t>product_title</a:t>
-            </a:r>
-            <a:r>
-              <a:rPr lang="en-GB" sz="2800" dirty="0"/>
-              <a:t>}}</a:t>
+              <a:t>{{part_number_1}}</a:t>
             </a:r>
             <a:endParaRPr lang="en-GB" sz="2800" b="1" i="0" dirty="0">
               <a:solidFill>

</xml_diff>